<commit_message>
Final presentation: reviewed slides, updated figures and notes; decision register intro shortened
</commit_message>
<xml_diff>
--- a/reports/job_market_presentation.pptx
+++ b/reports/job_market_presentation.pptx
@@ -654,7 +654,7 @@
           <a:p>
             <a:r>
               <a:rPr lang="en-US" dirty="0"/>
-              <a:t>For Task 7, the honest first step is to say what the data cannot measure: there is no remote field, so I do not invent a remote percentage. Instead I measure what is there. Client geography is stable, about 46 percent North America. Fixed-price work gains slightly. Words like remote appear in about half a percent of titles. The forecasts expect these signals to stay about where they are.</a:t>
+              <a:t>For Task 7, I first state what the data cannot measure: there is no remote or on-site field, so I do not estimate a remote-work percentage. Instead, I measure what is there. About 46% of jobs with a known client country come from North America, and this stays stable. The hourly share falls from 58.3% to 56.1%, so fixed-price work gains slightly. Explicit wording is rare: 1,260 of 229,520 postings have remote or home wording in the title, 199 mention a time-zone requirement and 171 mention on-site or in-person work. I also check how well the wording rules work. I use a separate sample and exclude titles identified as seen during rule development, although earlier records do not prove complete separation. About 91% of remote or home matches are correct, with a 95% interval from 85% to 95%. This measures the wording rule, not the percentage of jobs that allow remote work. The forecasts place the hourly share and the North American share close to their recent levels.</a:t>
             </a:r>
             <a:endParaRPr lang="en-US" dirty="0"/>
           </a:p>
@@ -742,7 +742,7 @@
           <a:p>
             <a:r>
               <a:rPr lang="en-US" dirty="0"/>
-              <a:t>For Task 5, I build a working recommender with a web page and an API. A freelancer types skills, the engine matches them to recent job titles and applies strict pay filters. I compare three matching methods in a blind test: I label the results without knowing which method returns them. The hybrid method wins under a rule fixed before scoring, with nDCG at 5 of 0.985. All three are close, so I do not claim one is better in general.</a:t>
+              <a:t>For Task 5, I build a working recommender with a web page and an API. A freelancer types skills, the engine matches them to recent job titles and applies strict pay and contract filters. I compare three matching methods. I label the pooled results myself, without knowing which method returns each job. Under a scoring rule fixed before labelling, the hybrid word-and-character TF-IDF method is selected, with nDCG@5 of 0.985 and strict Precision@5 of 0.967. nDCG@5 gives more credit when relevant jobs appear near the top of the list. The hybrid method has only one more relevant result than word TF-IDF in 60 evaluated slots, so I do not claim that it is better in general. The app serves this method only while its recorded approval remains valid. If the recommender code or settings change, the app stops until the result is reviewed again.</a:t>
             </a:r>
             <a:endParaRPr lang="en-US" dirty="0"/>
           </a:p>
@@ -830,7 +830,7 @@
           <a:p>
             <a:r>
               <a:rPr lang="en-US" dirty="0"/>
-              <a:t>For Task 6, I build a dashboard in the same app. It shows each month's headline numbers, weekly trends, pay, the country map and the forecasts. It computes nothing itself: it draws the verified tables. When a new monthly extract arrives, one rebuild updates the tables and the dashboard. An automated test proves that a new month appears without any code change.</a:t>
+              <a:t>For Task 6, I build a dashboard in the same app. It shows each month's headline numbers, weekly trends, pay, the country map and the forecasts. It computes nothing itself: it draws the verified tables. When a new monthly extract arrives, one rebuild updates the tables and the dashboard. An automated test checks that a new month appears without any code change.</a:t>
             </a:r>
             <a:endParaRPr lang="en-US" dirty="0"/>
           </a:p>
@@ -918,7 +918,7 @@
           <a:p>
             <a:r>
               <a:rPr lang="en-US" dirty="0"/>
-              <a:t>Why should anyone trust these results? On every push, GitHub runs 429 automated tests and builds the Docker images. SQL recomputes selected results from the raw rows and matches the pipeline. A rebuild on Linux keeps every reported result the same as on Windows. Git tags freeze each evaluation before I score it.</a:t>
+              <a:t>On every push, GitHub runs more than 500 automated tests, checks the committed notebooks and builds the Docker images. The official build is recorded with six input fingerprints, and two rebuilds from the same inputs give identical copies of all 54 analytical output files. All nine notebooks run in strict mode, and the project check reports 0 errors and 0 warnings. SQL recomputes selected results from the row-level data, and all 1,358 compared values match. The app serves only the approved recommender method. Git tags record the frozen category, recommender and work-arrangement evaluations. The forecast model and selection rule are fixed before the reserved final week is scored.</a:t>
             </a:r>
             <a:endParaRPr lang="en-US" dirty="0"/>
           </a:p>
@@ -1094,7 +1094,7 @@
           <a:p>
             <a:r>
               <a:rPr lang="en-US" dirty="0"/>
-              <a:t>Every result has limits, and I state them. The data has titles only and five reliable weeks. I am the only annotator. Pay means offers, not earnings, and the results are associations, not causes. With job descriptions, a longer history, a remote field and click data, the same pipeline could answer these questions more deeply.</a:t>
+              <a:t>Every result has limits, and I state them. The data has no job descriptions and only five reliable weeks. I am the only annotator for all labels. Pay means offers, not earnings, and the results are associations, not causes. The forecast ranges contain fewer final-week values than intended, and the recommender is selected by a margin of one result. More complete job information, a longer history and user activity data could help improve the categories, forecasts and recommendations.</a:t>
             </a:r>
             <a:endParaRPr lang="en-US" dirty="0"/>
           </a:p>
@@ -1358,7 +1358,7 @@
           <a:p>
             <a:r>
               <a:rPr lang="en-US" dirty="0"/>
-              <a:t>Before any analysis, I check what the data can and cannot answer. It has titles, pay, client country and time. It has no job descriptions and no remote field, so every result is about titles. Collection is complete only for 37 days, from 16 February to 23 March 2024, so all time-based results use that window. The chart shows the strong weekly rhythm, which is why I compare averages per day.</a:t>
+              <a:t>Before any analysis, I check what the data can and cannot answer. It has job titles, contract types, offered rates or budgets, client countries and posting times. It has no job descriptions and no remote or on-site field, so the categories, title-word results and recommendations depend on short titles. The reliable window covers 37 days, from 16 February to 23 March 2024. Three days still have small collection gaps, so I check whether these gaps affect the results. All time-based analysis uses this window. The chart shows a strong weekly rhythm, so I compare periods using averages per day.</a:t>
             </a:r>
             <a:endParaRPr lang="en-US" dirty="0"/>
           </a:p>
@@ -1446,7 +1446,7 @@
           <a:p>
             <a:r>
               <a:rPr lang="en-US" dirty="0"/>
-              <a:t>Everything comes from one pipeline. One command takes the raw file, cleans it, gives every job a category, runs the analyses and builds the outputs for the app, the dashboard and SQL. Three rules make the results trustworthy: I fix every rule before I see the final result, I test with blind human labels, and code checks every number I quote.</a:t>
+              <a:t>I use one pipeline to clean the data, assign job categories, run the analysis and prepare the results for the app, the dashboard and SQL. I develop the rules using development data, then fix them before the final evaluation. I test the categories and the recommender with blind human labels, and code checks selected figures against the saved outputs.</a:t>
             </a:r>
             <a:endParaRPr lang="en-US" dirty="0"/>
           </a:p>
@@ -1534,7 +1534,7 @@
           <a:p>
             <a:r>
               <a:rPr lang="en-US" dirty="0"/>
-              <a:t>The data has no category, so I build one: 22 job functions plus Other. Transparent rules decide 87 percent of jobs. I test the system on 350 titles that I label blind, before I score it once. It agrees with me 68.9 percent of the time. I report this honestly, and I keep in mind that some areas, like Software and AI, are undercounted.</a:t>
+              <a:t>The data has no category field, so I build one: 22 job functions plus Other / Unclear. Keyword rules assign 86.6% of jobs, and a guarded classifier adds another 1.2%. I compare the system's predictions with my own labels for 350 titles. I label these titles without seeing the system's predictions, and I keep the category rules fixed before the final evaluation. The system agrees with my label for 68.9% of titles, with a 95% interval from 63.8% to 73.5%. Some categories, such as Software &amp; IT and AI &amp; Machine Learning, are likely undercounted, because many of their titles fall into Other / Unclear.</a:t>
             </a:r>
             <a:endParaRPr lang="en-US" dirty="0"/>
           </a:p>
@@ -1710,7 +1710,7 @@
           <a:p>
             <a:r>
               <a:rPr lang="en-US" dirty="0"/>
-              <a:t>For Task 2, I measure each job function's share of daily posts across the five weeks. Nine of 22 functions change significantly. Marketing, Video, Design, Sales, E-commerce and AI gain share; Writing, Admin and Translation lose it. Part of this happens as one step around 26 February. These are short-term shifts, not long-run trends.</a:t>
+              <a:t>For Task 2, I measure each job function's share of daily posts across the five weeks. Nine of 22 functions change significantly. Digital Marketing, Video &amp; Animation, Design &amp; Creative, Sales &amp; Lead Generation, E-commerce Operations and AI &amp; Machine Learning gain share; Writing &amp; Content, Admin &amp; Virtual Assistance and Translation &amp; Transcription lose it. All nine directions hold without possible reposts, without days with collection gaps and in a complete-week comparison, although the sizes vary. Part of the change is one step around 26 February. After that step, four categories keep changing clearly: Writing &amp; Content falls, while AI &amp; Machine Learning, Sales &amp; Lead Generation and E-commerce Operations rise. These are short-term shifts, not long-run trends.</a:t>
             </a:r>
             <a:endParaRPr lang="en-US" dirty="0"/>
           </a:p>
@@ -1798,7 +1798,7 @@
           <a:p>
             <a:r>
               <a:rPr lang="en-US" dirty="0"/>
-              <a:t>For Task 4, I compare 91 client countries. I show two views: the typical offer, and an index for the same kinds of jobs. US clients offer the highest typical rate among large markets, 25 dollars an hour, about 9 percent above average for the same work. The job mix changes the picture: Australia looks average, but offers about 12 percent less for the same work.</a:t>
+              <a:t>For Task 4, I compare 91 client countries. I show the median offer, the mean offer and an index for the same kinds of jobs. Among countries with at least 2,000 rated jobs, US clients have the highest median, USD 25 per hour, and their mean is USD 32.6. The mean is above the median in 89 of the 91 countries, because a small number of high offers pulls the averages up. After adjusting for job categories, the US index is about 9% above the reference level. The job mix changes the picture: Australia's median is near average, but its adjusted index is about 12% below. These are offers in postings, not what freelancers earn.</a:t>
             </a:r>
             <a:endParaRPr lang="en-US" dirty="0"/>
           </a:p>
@@ -1886,7 +1886,7 @@
           <a:p>
             <a:r>
               <a:rPr lang="en-US" dirty="0"/>
-              <a:t>For Tasks 3 and 8, I forecast 14 days ahead. A weekday-mean model wins under a rule fixed in advance. Web Development, Design and Marketing lead with about 900, 715 and 665 jobs a day. I keep three things apart: the central outlook, the uncertainty range from past errors, and a trend-continuation scenario. A big past change does not mean the change continues.</a:t>
+              <a:t>For Tasks 3 and 8, I forecast 14 days ahead. I compare four simple models and select the weekday mean because it has the lowest average seasonal MASE in the development backtests. Seasonal MASE compares a model's error with the usual week-to-week change. The weekday mean is not better on every measure: for total jobs, the simple seasonal baseline forecasts better in both the development backtests and the final week. Web Development, Design &amp; Creative and Digital Marketing lead the next week with about 900, 720 and 660 jobs a day, and the last two have overlapping ranges. The ranges come from past forecast errors. When I build ranges the same way from the development period and test them on the reserved final week, they contain 75.0% of the demand values, below the intended 80%. This tests the method, not the future ranges themselves. A separate damped-trend model suggests small rises for four categories, but the trend after 26 February does not clearly support three of them, so these are possible directions, not established trends.</a:t>
             </a:r>
             <a:endParaRPr lang="en-US" dirty="0"/>
           </a:p>
@@ -2491,8 +2491,8 @@
         </p:nvSpPr>
         <p:spPr>
           <a:xfrm>
-            <a:off x="822960" y="1463040"/>
-            <a:ext cx="10515600" cy="457200"/>
+            <a:off x="822960" y="1554480"/>
+            <a:ext cx="10515600" cy="1097280"/>
           </a:xfrm>
           <a:prstGeom prst="rect">
             <a:avLst/>
@@ -2508,14 +2508,14 @@
               <a:buNone/>
             </a:pPr>
             <a:r>
-              <a:rPr lang="en-US" sz="2000" spc="200" kern="0" dirty="0">
-                <a:solidFill>
-                  <a:schemeClr val="accent6"/>
+              <a:rPr lang="en-US" sz="5400" b="1" dirty="0">
+                <a:solidFill>
+                  <a:schemeClr val="bg1"/>
                 </a:solidFill>
               </a:rPr>
               <a:t>NextHikes IT Solutions</a:t>
             </a:r>
-            <a:endParaRPr lang="en-US" sz="2000" dirty="0"/>
+            <a:endParaRPr lang="en-US" sz="5400" dirty="0"/>
           </a:p>
         </p:txBody>
       </p:sp>
@@ -2527,8 +2527,8 @@
         </p:nvSpPr>
         <p:spPr>
           <a:xfrm>
-            <a:off x="822960" y="2057400"/>
-            <a:ext cx="10515600" cy="1737360"/>
+            <a:off x="822960" y="2834640"/>
+            <a:ext cx="10515600" cy="1097280"/>
           </a:xfrm>
           <a:prstGeom prst="rect">
             <a:avLst/>
@@ -2544,14 +2544,14 @@
               <a:buNone/>
             </a:pPr>
             <a:r>
-              <a:rPr lang="en-US" sz="4600" b="1" dirty="0">
-                <a:solidFill>
-                  <a:schemeClr val="bg1"/>
+              <a:rPr lang="en-US" sz="3000" dirty="0">
+                <a:solidFill>
+                  <a:schemeClr val="accent6"/>
                 </a:solidFill>
               </a:rPr>
               <a:t>Job Market Analysis and Recommendation System</a:t>
             </a:r>
-            <a:endParaRPr lang="en-US" sz="4600" dirty="0"/>
+            <a:endParaRPr lang="en-US" sz="3000" dirty="0"/>
           </a:p>
         </p:txBody>
       </p:sp>
@@ -2563,7 +2563,7 @@
         </p:nvSpPr>
         <p:spPr>
           <a:xfrm>
-            <a:off x="822960" y="4434840"/>
+            <a:off x="822960" y="4389120"/>
             <a:ext cx="10515600" cy="457200"/>
           </a:xfrm>
           <a:prstGeom prst="rect">
@@ -2588,6 +2588,42 @@
               <a:t>Manisha Nagda</a:t>
             </a:r>
             <a:endParaRPr lang="en-US" sz="2200" dirty="0"/>
+          </a:p>
+        </p:txBody>
+      </p:sp>
+      <p:sp>
+        <p:nvSpPr>
+          <p:cNvPr id="5" name="date"/>
+          <p:cNvSpPr txBox="1"/>
+          <p:nvPr/>
+        </p:nvSpPr>
+        <p:spPr>
+          <a:xfrm>
+            <a:off x="822960" y="4937760"/>
+            <a:ext cx="10515600" cy="411480"/>
+          </a:xfrm>
+          <a:prstGeom prst="rect">
+            <a:avLst/>
+          </a:prstGeom>
+          <a:noFill/>
+          <a:ln/>
+        </p:spPr>
+        <p:txBody>
+          <a:bodyPr wrap="square" lIns="0" tIns="0" rIns="0" bIns="0" rtlCol="0" anchor="ctr"/>
+          <a:lstStyle/>
+          <a:p>
+            <a:pPr indent="0" marL="0">
+              <a:buNone/>
+            </a:pPr>
+            <a:r>
+              <a:rPr lang="en-US" sz="1800" dirty="0">
+                <a:solidFill>
+                  <a:schemeClr val="bg1"/>
+                </a:solidFill>
+              </a:rPr>
+              <a:t>October 2026</a:t>
+            </a:r>
+            <a:endParaRPr lang="en-US" sz="1800" dirty="0"/>
           </a:p>
         </p:txBody>
       </p:sp>
@@ -2724,7 +2760,7 @@
                   <a:schemeClr val="accent1"/>
                 </a:solidFill>
               </a:rPr>
-              <a:t>The data has no remote / on-site field, so I do not invent a remote-work percentage.</a:t>
+              <a:t>The data has no remote or on-site field, so it cannot show the actual percentage of remote jobs.</a:t>
             </a:r>
             <a:endParaRPr lang="en-US" sz="1800" dirty="0"/>
           </a:p>
@@ -2801,7 +2837,7 @@
                   <a:schemeClr val="tx1"/>
                 </a:solidFill>
               </a:rPr>
-              <a:t>of clients are in North America; stable over the window</a:t>
+              <a:t>of jobs with a known client country come from North America; stable</a:t>
             </a:r>
             <a:endParaRPr lang="en-US" sz="2400" dirty="0"/>
           </a:p>
@@ -2941,7 +2977,7 @@
                   <a:schemeClr val="accent2"/>
                 </a:solidFill>
               </a:rPr>
-              <a:t>about 0.5%</a:t>
+              <a:t>0.55%</a:t>
             </a:r>
             <a:endParaRPr lang="en-US" sz="2400" dirty="0"/>
           </a:p>
@@ -2955,7 +2991,7 @@
                   <a:schemeClr val="tx1"/>
                 </a:solidFill>
               </a:rPr>
-              <a:t>of titles say “remote”; on-site under 0.1%</a:t>
+              <a:t>of postings have remote or home wording in the title; the audit finds 91% of matches correct</a:t>
             </a:r>
             <a:endParaRPr lang="en-US" sz="2400" dirty="0"/>
           </a:p>
@@ -2977,8 +3013,8 @@
         </p:blipFill>
         <p:spPr>
           <a:xfrm>
-            <a:off x="5577840" y="2011680"/>
-            <a:ext cx="5486400" cy="3832268"/>
+            <a:off x="5682120" y="2011680"/>
+            <a:ext cx="5277839" cy="3832268"/>
           </a:xfrm>
           <a:prstGeom prst="rect">
             <a:avLst/>
@@ -3015,7 +3051,7 @@
                   <a:schemeClr val="accent5"/>
                 </a:solidFill>
               </a:rPr>
-              <a:t>Daily hourly share and North American client share, then the 14-day forecast with its range.</a:t>
+              <a:t>Daily hourly share and North American client share, then the 14-day forecast with its two ranges.</a:t>
             </a:r>
             <a:endParaRPr lang="en-US" sz="1100" dirty="0"/>
           </a:p>
@@ -3556,7 +3592,7 @@
                   <a:schemeClr val="tx1"/>
                 </a:solidFill>
               </a:rPr>
-              <a:t>Blind test, 12 profiles:  </a:t>
+              <a:t>12 profiles:  </a:t>
             </a:r>
             <a:pPr indent="0" marL="0">
               <a:buNone/>
@@ -3567,7 +3603,7 @@
                   <a:schemeClr val="accent1"/>
                 </a:solidFill>
               </a:rPr>
-              <a:t>nDCG@5 0.985  ·  Precision@5 0.967</a:t>
+              <a:t>nDCG@5 0.985  ·  Precision@5 0.967  ·  one-result margin</a:t>
             </a:r>
             <a:endParaRPr lang="en-US" sz="1400" dirty="0"/>
           </a:p>
@@ -3589,8 +3625,8 @@
         </p:blipFill>
         <p:spPr>
           <a:xfrm>
-            <a:off x="6309360" y="4526280"/>
-            <a:ext cx="5303520" cy="1788859"/>
+            <a:off x="6271194" y="4526280"/>
+            <a:ext cx="5379852" cy="1788859"/>
           </a:xfrm>
           <a:prstGeom prst="rect">
             <a:avLst/>
@@ -4234,46 +4270,49 @@
                   <a:schemeClr val="tx1"/>
                 </a:solidFill>
               </a:rPr>
-              <a:t>Why the results can be trusted</a:t>
+              <a:t>How the results are checked</a:t>
             </a:r>
             <a:endParaRPr lang="en-US" sz="3000" dirty="0"/>
           </a:p>
         </p:txBody>
       </p:sp>
-      <p:pic>
-        <p:nvPicPr>
-          <p:cNvPr id="3" name="ci screenshot run 25" descr="/home/claude/deck/assets/ci_run25.png">    </p:cNvPr>
-          <p:cNvPicPr>
-            <a:picLocks noChangeAspect="1"/>
-          </p:cNvPicPr>
-          <p:nvPr/>
-        </p:nvPicPr>
-        <p:blipFill>
-          <a:blip r:embed="rId1"/>
-          <a:stretch>
-            <a:fillRect/>
-          </a:stretch>
-        </p:blipFill>
+      <p:sp>
+        <p:nvSpPr>
+          <p:cNvPr id="20" name="official build card"/>
+          <p:cNvSpPr/>
+          <p:nvPr/>
+        </p:nvSpPr>
         <p:spPr>
           <a:xfrm>
             <a:off x="548640" y="1463040"/>
-            <a:ext cx="6217920" cy="2232955"/>
-          </a:xfrm>
-          <a:prstGeom prst="rect">
-            <a:avLst/>
-          </a:prstGeom>
-        </p:spPr>
-      </p:pic>
-      <p:sp>
-        <p:nvSpPr>
-          <p:cNvPr id="4" name="caption"/>
+            <a:ext cx="6217920" cy="2834640"/>
+          </a:xfrm>
+          <a:prstGeom prst="roundRect">
+            <a:avLst>
+              <a:gd name="adj" fmla="val 2020"/>
+            </a:avLst>
+          </a:prstGeom>
+          <a:solidFill>
+            <a:schemeClr val="tx2"/>
+          </a:solidFill>
+          <a:ln w="12700">
+            <a:solidFill>
+              <a:schemeClr val="tx2"/>
+            </a:solidFill>
+            <a:prstDash val="solid"/>
+          </a:ln>
+        </p:spPr>
+      </p:sp>
+      <p:sp>
+        <p:nvSpPr>
+          <p:cNvPr id="21" name="official build facts"/>
           <p:cNvSpPr txBox="1"/>
           <p:nvPr/>
         </p:nvSpPr>
         <p:spPr>
           <a:xfrm>
-            <a:off x="548640" y="3840480"/>
-            <a:ext cx="6217920" cy="320040"/>
+            <a:off x="822960" y="1691640"/>
+            <a:ext cx="5669280" cy="2468880"/>
           </a:xfrm>
           <a:prstGeom prst="rect">
             <a:avLst/>
@@ -4282,21 +4321,129 @@
           <a:ln/>
         </p:spPr>
         <p:txBody>
-          <a:bodyPr wrap="square" lIns="0" tIns="0" rIns="0" bIns="0" rtlCol="0" anchor="ctr"/>
+          <a:bodyPr wrap="square" lIns="0" tIns="0" rIns="0" bIns="0" rtlCol="0" anchor="t"/>
           <a:lstStyle/>
           <a:p>
             <a:pPr indent="0" marL="0">
               <a:buNone/>
             </a:pPr>
             <a:r>
-              <a:rPr lang="en-US" sz="1100" i="1" dirty="0">
-                <a:solidFill>
-                  <a:schemeClr val="accent5"/>
-                </a:solidFill>
-              </a:rPr>
-              <a:t>GitHub Actions, run #25: the test and docker jobs both pass on every push.</a:t>
-            </a:r>
-            <a:endParaRPr lang="en-US" sz="1100" dirty="0"/>
+              <a:rPr lang="en-US" sz="2000" b="1" dirty="0">
+                <a:solidFill>
+                  <a:schemeClr val="bg1"/>
+                </a:solidFill>
+              </a:rPr>
+              <a:t>Official build</a:t>
+            </a:r>
+          </a:p>
+          <a:p>
+            <a:pPr indent="0" marL="0">
+              <a:buNone/>
+            </a:pPr>
+            <a:r>
+              <a:rPr lang="en-US" sz="1200" dirty="0">
+                <a:solidFill>
+                  <a:schemeClr val="accent6"/>
+                </a:solidFill>
+              </a:rPr>
+              <a:t>20261011T132714Z-e537465460</a:t>
+            </a:r>
+          </a:p>
+          <a:p>
+            <a:pPr indent="0" marL="0">
+              <a:spcBef>
+                <a:spcPts val="900"/>
+              </a:spcBef>
+              <a:buNone/>
+            </a:pPr>
+            <a:r>
+              <a:rPr lang="en-US" sz="1500" b="1" dirty="0">
+                <a:solidFill>
+                  <a:schemeClr val="bg1"/>
+                </a:solidFill>
+              </a:rPr>
+              <a:t>6 input fingerprints</a:t>
+            </a:r>
+            <a:r>
+              <a:rPr lang="en-US" sz="1300" dirty="0">
+                <a:solidFill>
+                  <a:schemeClr val="bg1"/>
+                </a:solidFill>
+              </a:rPr>
+              <a:t>  raw data, settings, code, environment, SQL and label inputs</a:t>
+            </a:r>
+          </a:p>
+          <a:p>
+            <a:pPr indent="0" marL="0">
+              <a:spcBef>
+                <a:spcPts val="900"/>
+              </a:spcBef>
+              <a:buNone/>
+            </a:pPr>
+            <a:r>
+              <a:rPr lang="en-US" sz="1500" b="1" dirty="0">
+                <a:solidFill>
+                  <a:schemeClr val="bg1"/>
+                </a:solidFill>
+              </a:rPr>
+              <a:t>54 of 54 analytical files</a:t>
+            </a:r>
+            <a:r>
+              <a:rPr lang="en-US" sz="1300" dirty="0">
+                <a:solidFill>
+                  <a:schemeClr val="bg1"/>
+                </a:solidFill>
+              </a:rPr>
+              <a:t>  identical across two rebuilds from the same inputs</a:t>
+            </a:r>
+          </a:p>
+          <a:p>
+            <a:pPr indent="0" marL="0">
+              <a:spcBef>
+                <a:spcPts val="900"/>
+              </a:spcBef>
+              <a:buNone/>
+            </a:pPr>
+            <a:r>
+              <a:rPr lang="en-US" sz="1500" b="1" dirty="0">
+                <a:solidFill>
+                  <a:schemeClr val="bg1"/>
+                </a:solidFill>
+              </a:rPr>
+              <a:t>0 errors, 0 warnings</a:t>
+            </a:r>
+            <a:r>
+              <a:rPr lang="en-US" sz="1300" dirty="0">
+                <a:solidFill>
+                  <a:schemeClr val="bg1"/>
+                </a:solidFill>
+              </a:rPr>
+              <a:t>  strict project check; all 9 notebooks rerun on this build</a:t>
+            </a:r>
+          </a:p>
+          <a:p>
+            <a:pPr indent="0" marL="0">
+              <a:spcBef>
+                <a:spcPts val="900"/>
+              </a:spcBef>
+              <a:buNone/>
+            </a:pPr>
+            <a:r>
+              <a:rPr lang="en-US" sz="1500" b="1" dirty="0">
+                <a:solidFill>
+                  <a:schemeClr val="bg1"/>
+                </a:solidFill>
+              </a:rPr>
+              <a:t>1,358 values</a:t>
+            </a:r>
+            <a:r>
+              <a:rPr lang="en-US" sz="1300" dirty="0">
+                <a:solidFill>
+                  <a:schemeClr val="bg1"/>
+                </a:solidFill>
+              </a:rPr>
+              <a:t>  SQL recomputes selected results and every compared value matches</a:t>
+            </a:r>
           </a:p>
         </p:txBody>
       </p:sp>
@@ -4357,7 +4504,7 @@
                   <a:schemeClr val="accent1"/>
                 </a:solidFill>
               </a:rPr>
-              <a:t>429</a:t>
+              <a:t>500+</a:t>
             </a:r>
             <a:endParaRPr lang="en-US" sz="2200" dirty="0"/>
           </a:p>
@@ -4434,7 +4581,7 @@
                   <a:schemeClr val="accent1"/>
                 </a:solidFill>
               </a:rPr>
-              <a:t>SQL</a:t>
+              <a:t>Approval</a:t>
             </a:r>
             <a:endParaRPr lang="en-US" sz="2200" dirty="0"/>
           </a:p>
@@ -4448,7 +4595,7 @@
                   <a:schemeClr val="tx1"/>
                 </a:solidFill>
               </a:rPr>
-              <a:t>reproduces selected results from row-level data</a:t>
+              <a:t>the app serves only the approved recommender method</a:t>
             </a:r>
             <a:endParaRPr lang="en-US" sz="2200" dirty="0"/>
           </a:p>
@@ -4511,7 +4658,7 @@
                   <a:schemeClr val="accent1"/>
                 </a:solidFill>
               </a:rPr>
-              <a:t>Windows = Linux</a:t>
+              <a:t>Claims checks</a:t>
             </a:r>
             <a:endParaRPr lang="en-US" sz="2200" dirty="0"/>
           </a:p>
@@ -4525,7 +4672,7 @@
                   <a:schemeClr val="tx1"/>
                 </a:solidFill>
               </a:rPr>
-              <a:t>every reported result stays the same</a:t>
+              <a:t>notebooks and report tests compare selected figures with the outputs</a:t>
             </a:r>
             <a:endParaRPr lang="en-US" sz="2200" dirty="0"/>
           </a:p>
@@ -4602,7 +4749,7 @@
                   <a:schemeClr val="tx1"/>
                 </a:solidFill>
               </a:rPr>
-              <a:t>freeze the final evaluations</a:t>
+              <a:t>record the frozen label-based evaluations</a:t>
             </a:r>
             <a:endParaRPr lang="en-US" sz="2200" dirty="0"/>
           </a:p>
@@ -4638,7 +4785,7 @@
                   <a:schemeClr val="tx1"/>
                 </a:solidFill>
               </a:rPr>
-              <a:t>Every number quoted in a notebook, the README or the report is checked against the data by code.</a:t>
+              <a:t>A Windows and Linux comparison of an earlier build matched except two files with small floating-point differences. It has not yet been repeated for the official build.</a:t>
             </a:r>
             <a:endParaRPr lang="en-US" sz="1600" dirty="0"/>
           </a:p>
@@ -5423,7 +5570,7 @@
         <p:spPr>
           <a:xfrm>
             <a:off x="548640" y="1463040"/>
-            <a:ext cx="5394960" cy="3383280"/>
+            <a:ext cx="5394960" cy="4206240"/>
           </a:xfrm>
           <a:prstGeom prst="roundRect">
             <a:avLst>
@@ -5450,7 +5597,7 @@
         <p:spPr>
           <a:xfrm>
             <a:off x="822960" y="1737360"/>
-            <a:ext cx="4937760" cy="4023360"/>
+            <a:ext cx="4937760" cy="3840480"/>
           </a:xfrm>
           <a:prstGeom prst="rect">
             <a:avLst/>
@@ -5492,7 +5639,7 @@
                   <a:schemeClr val="tx1"/>
                 </a:solidFill>
               </a:rPr>
-              <a:t>Titles only, no job descriptions</a:t>
+              <a:t>No job descriptions or skills lists</a:t>
             </a:r>
             <a:endParaRPr lang="en-US" sz="1800" dirty="0"/>
           </a:p>
@@ -5568,6 +5715,42 @@
             </a:r>
             <a:endParaRPr lang="en-US" sz="1800" dirty="0"/>
           </a:p>
+          <a:p>
+            <a:pPr marL="342900" indent="-342900">
+              <a:spcAft>
+                <a:spcPts val="1600"/>
+              </a:spcAft>
+              <a:buSzPct val="100000"/>
+              <a:buChar char="•"/>
+            </a:pPr>
+            <a:r>
+              <a:rPr lang="en-US" sz="1800" dirty="0">
+                <a:solidFill>
+                  <a:schemeClr val="tx1"/>
+                </a:solidFill>
+              </a:rPr>
+              <a:t>Forecast ranges cover fewer values than intended</a:t>
+            </a:r>
+            <a:endParaRPr lang="en-US" sz="1800" dirty="0"/>
+          </a:p>
+          <a:p>
+            <a:pPr marL="342900" indent="-342900">
+              <a:spcAft>
+                <a:spcPts val="1600"/>
+              </a:spcAft>
+              <a:buSzPct val="100000"/>
+              <a:buChar char="•"/>
+            </a:pPr>
+            <a:r>
+              <a:rPr lang="en-US" sz="1800" dirty="0">
+                <a:solidFill>
+                  <a:schemeClr val="tx1"/>
+                </a:solidFill>
+              </a:rPr>
+              <a:t>Recommender margin of one result</a:t>
+            </a:r>
+            <a:endParaRPr lang="en-US" sz="1800" dirty="0"/>
+          </a:p>
         </p:txBody>
       </p:sp>
       <p:sp>
@@ -5579,7 +5762,7 @@
         <p:spPr>
           <a:xfrm>
             <a:off x="6217920" y="1463040"/>
-            <a:ext cx="5394960" cy="3383280"/>
+            <a:ext cx="5394960" cy="4206240"/>
           </a:xfrm>
           <a:prstGeom prst="roundRect">
             <a:avLst>
@@ -5606,7 +5789,7 @@
         <p:spPr>
           <a:xfrm>
             <a:off x="6492240" y="1737360"/>
-            <a:ext cx="4937760" cy="4023360"/>
+            <a:ext cx="4937760" cy="3840480"/>
           </a:xfrm>
           <a:prstGeom prst="rect">
             <a:avLst/>
@@ -7235,7 +7418,7 @@
                   <a:schemeClr val="tx1"/>
                 </a:solidFill>
               </a:rPr>
-              <a:t>First: what can the data honestly answer?</a:t>
+              <a:t>First: what the data can and cannot answer</a:t>
             </a:r>
             <a:endParaRPr lang="en-US" sz="3000" dirty="0"/>
           </a:p>
@@ -7567,7 +7750,7 @@
                   <a:schemeClr val="tx1"/>
                 </a:solidFill>
               </a:rPr>
-              <a:t>reliable window, 16 Feb - 23 Mar 2024</a:t>
+              <a:t>reliable window, 16 Feb to 23 Mar 2024</a:t>
             </a:r>
             <a:endParaRPr lang="en-US" sz="3000" dirty="0"/>
           </a:p>
@@ -7725,7 +7908,7 @@
                   <a:schemeClr val="tx1"/>
                 </a:solidFill>
               </a:rPr>
-              <a:t>How I work: one pipeline, rules fixed first</a:t>
+              <a:t>How I work: one pipeline, rules fixed before evaluation</a:t>
             </a:r>
             <a:endParaRPr lang="en-US" sz="3000" dirty="0"/>
           </a:p>
@@ -7992,7 +8175,7 @@
                   <a:schemeClr val="bg1"/>
                 </a:solidFill>
               </a:rPr>
-              <a:t>Categorize</a:t>
+              <a:t>Categorise</a:t>
             </a:r>
             <a:endParaRPr lang="en-US" sz="1600" dirty="0"/>
           </a:p>
@@ -8424,7 +8607,7 @@
                   <a:schemeClr val="tx1"/>
                 </a:solidFill>
               </a:rPr>
-              <a:t>Rules fixed before results</a:t>
+              <a:t>Rules fixed before final evaluation</a:t>
             </a:r>
             <a:endParaRPr lang="en-US" sz="1700" dirty="0"/>
           </a:p>
@@ -8460,7 +8643,7 @@
                   <a:schemeClr val="tx1"/>
                 </a:solidFill>
               </a:rPr>
-              <a:t>Models, thresholds and scoring rules are set before I see any final result.</a:t>
+              <a:t>I use development data to choose the rules and settings, then keep them fixed for the final evaluation.</a:t>
             </a:r>
             <a:endParaRPr lang="en-US" sz="1400" dirty="0"/>
           </a:p>
@@ -8720,7 +8903,7 @@
                   <a:schemeClr val="tx1"/>
                 </a:solidFill>
               </a:rPr>
-              <a:t>Every number checked by code</a:t>
+              <a:t>Selected figures checked by code</a:t>
             </a:r>
             <a:endParaRPr lang="en-US" sz="1700" dirty="0"/>
           </a:p>
@@ -8955,7 +9138,7 @@
                   <a:schemeClr val="accent6"/>
                 </a:solidFill>
               </a:rPr>
-              <a:t>241 of 350 titles  ·  95% interval 63.8% - 73.5%</a:t>
+              <a:t>241 of 350 titles  ·  95% interval 63.8% to 73.5%</a:t>
             </a:r>
             <a:endParaRPr lang="en-US" sz="6600" dirty="0"/>
           </a:p>
@@ -9163,7 +9346,7 @@
                   <a:schemeClr val="accent1"/>
                 </a:solidFill>
               </a:rPr>
-              <a:t>87% decided by rules</a:t>
+              <a:t>86.6% decided by rules</a:t>
             </a:r>
             <a:endParaRPr lang="en-US" sz="3000" dirty="0"/>
           </a:p>
@@ -9177,7 +9360,7 @@
                   <a:schemeClr val="tx1"/>
                 </a:solidFill>
               </a:rPr>
-              <a:t>transparent keyword rules; a guarded classifier adds about 1%</a:t>
+              <a:t>transparent keyword rules; a guarded classifier adds 1.2%</a:t>
             </a:r>
             <a:endParaRPr lang="en-US" sz="3000" dirty="0"/>
           </a:p>
@@ -9263,7 +9446,7 @@
                   <a:schemeClr val="accent5"/>
                 </a:solidFill>
               </a:rPr>
-              <a:t>Software &amp; IT, AI &amp; ML, Engineering and Admin are likely undercounted, so I show the Other share next to every category result.</a:t>
+              <a:t>Software &amp; IT, AI &amp; Machine Learning, Engineering &amp; Architecture and Admin &amp; Virtual Assistance are likely undercounted, so I show the Other share next to category results.</a:t>
             </a:r>
             <a:endParaRPr lang="en-US" sz="1400" dirty="0"/>
           </a:p>
@@ -9657,7 +9840,7 @@
                   <a:schemeClr val="accent5"/>
                 </a:solidFill>
               </a:rPr>
-              <a:t>Difference in hourly offer vs. jobs in the same client country and category; black lines are 95% intervals.</a:t>
+              <a:t>Difference in hourly offer compared with jobs in the same client country and category; black lines are 95% intervals.</a:t>
             </a:r>
             <a:endParaRPr lang="en-US" sz="1100" dirty="0"/>
           </a:p>
@@ -9904,7 +10087,7 @@
                   <a:schemeClr val="tx1"/>
                 </a:solidFill>
               </a:rPr>
-              <a:t>Video, Design, Sales, E-commerce</a:t>
+              <a:t>Video &amp; Animation, Design &amp; Creative, Sales &amp; Lead Generation, E-commerce Operations</a:t>
             </a:r>
             <a:endParaRPr lang="en-US" sz="1400" dirty="0"/>
           </a:p>
@@ -9979,7 +10162,7 @@
                   <a:schemeClr val="tx1"/>
                 </a:solidFill>
               </a:rPr>
-              <a:t>Writing  5.8% → 3.7% of posts</a:t>
+              <a:t>Writing &amp; Content  5.8% → 3.7% of posts</a:t>
             </a:r>
             <a:endParaRPr lang="en-US" sz="1400" dirty="0"/>
           </a:p>
@@ -9997,7 +10180,7 @@
                   <a:schemeClr val="tx1"/>
                 </a:solidFill>
               </a:rPr>
-              <a:t>Admin  −1.4 points</a:t>
+              <a:t>Admin &amp; Virtual Assistance  −1.4 points</a:t>
             </a:r>
             <a:endParaRPr lang="en-US" sz="1400" dirty="0"/>
           </a:p>
@@ -10015,7 +10198,7 @@
                   <a:schemeClr val="tx1"/>
                 </a:solidFill>
               </a:rPr>
-              <a:t>Translation  −0.9 points</a:t>
+              <a:t>Translation &amp; Transcription  −0.9 points</a:t>
             </a:r>
             <a:endParaRPr lang="en-US" sz="1400" dirty="0"/>
           </a:p>
@@ -10345,7 +10528,7 @@
                   <a:schemeClr val="accent1"/>
                 </a:solidFill>
               </a:rPr>
-              <a:t>$25 / hour</a:t>
+              <a:t>USD 25 per hour</a:t>
             </a:r>
             <a:endParaRPr lang="en-US" sz="3000" dirty="0"/>
           </a:p>
@@ -10359,7 +10542,7 @@
                   <a:schemeClr val="tx1"/>
                 </a:solidFill>
               </a:rPr>
-              <a:t>US median, about +9% for the same kinds of jobs</a:t>
+              <a:t>US median; mean USD 32.6; adjusted index +9%</a:t>
             </a:r>
             <a:endParaRPr lang="en-US" sz="3000" dirty="0"/>
           </a:p>
@@ -10653,7 +10836,7 @@
                   <a:schemeClr val="accent1"/>
                 </a:solidFill>
               </a:rPr>
-              <a:t>about 900 · 715 · 665</a:t>
+              <a:t>about 900 · 720 · 660</a:t>
             </a:r>
             <a:endParaRPr lang="en-US" sz="2600" dirty="0"/>
           </a:p>
@@ -10667,7 +10850,7 @@
                   <a:schemeClr val="tx1"/>
                 </a:solidFill>
               </a:rPr>
-              <a:t>jobs a day: Web Development, Design, Marketing</a:t>
+              <a:t>jobs a day: Web Development, Design &amp; Creative, Digital Marketing</a:t>
             </a:r>
             <a:endParaRPr lang="en-US" sz="2600" dirty="0"/>
           </a:p>
@@ -10807,7 +10990,7 @@
                   <a:schemeClr val="tx1"/>
                 </a:solidFill>
               </a:rPr>
-              <a:t>80% empirical range</a:t>
+              <a:t>Intended 80% range</a:t>
             </a:r>
             <a:endParaRPr lang="en-US" sz="1400" dirty="0"/>
           </a:p>
@@ -10821,7 +11004,7 @@
                   <a:schemeClr val="tx1"/>
                 </a:solidFill>
               </a:rPr>
-              <a:t>5,930 - 6,310 a day (days 1-7)</a:t>
+              <a:t>5,930 to 6,300 a day (days 1 to 7)</a:t>
             </a:r>
             <a:endParaRPr lang="en-US" sz="1400" dirty="0"/>
           </a:p>
@@ -10884,7 +11067,7 @@
                   <a:schemeClr val="tx1"/>
                 </a:solidFill>
               </a:rPr>
-              <a:t>Trend continuation</a:t>
+              <a:t>Possible directions</a:t>
             </a:r>
             <a:endParaRPr lang="en-US" sz="1400" dirty="0"/>
           </a:p>
@@ -10898,7 +11081,7 @@
                   <a:schemeClr val="tx1"/>
                 </a:solidFill>
               </a:rPr>
-              <a:t>rising only for Marketing, Video, Design</a:t>
+              <a:t>small rises for 4 categories, not established trends</a:t>
             </a:r>
             <a:endParaRPr lang="en-US" sz="1400" dirty="0"/>
           </a:p>
@@ -10934,7 +11117,7 @@
                   <a:schemeClr val="accent5"/>
                 </a:solidFill>
               </a:rPr>
-              <a:t>Final-week test: the model beats the simple baseline for 20 of 23 categories, but not for total volume.</a:t>
+              <a:t>Final week: better than the baseline for 20 of 23 categories, not for total jobs; ranges built the same way contain 75.0% of values.</a:t>
             </a:r>
             <a:endParaRPr lang="en-US" sz="1400" dirty="0"/>
           </a:p>
@@ -10970,7 +11153,7 @@
                   <a:schemeClr val="accent5"/>
                 </a:solidFill>
               </a:rPr>
-              <a:t>Forecast jobs per day, 24-30 March 2024, with 80% empirical ranges; overlapping ranges mean similar demand.</a:t>
+              <a:t>Forecast jobs per day, 24 to 30 March 2024, with intended 80% ranges; overlapping ranges mean similar demand.</a:t>
             </a:r>
             <a:endParaRPr lang="en-US" sz="1100" dirty="0"/>
           </a:p>

</xml_diff>

<commit_message>
Cross-platform check of the official build and Docker application test documented in report, slides and decision log
</commit_message>
<xml_diff>
--- a/reports/job_market_presentation.pptx
+++ b/reports/job_market_presentation.pptx
@@ -918,7 +918,7 @@
           <a:p>
             <a:r>
               <a:rPr lang="en-US" dirty="0"/>
-              <a:t>On every push, GitHub runs more than 500 automated tests, checks the committed notebooks and builds the Docker images. The official build is recorded with six input fingerprints, and two rebuilds from the same inputs give identical copies of all 54 analytical output files. All nine notebooks run in strict mode, and the project check reports 0 errors and 0 warnings. SQL recomputes selected results from the row-level data, and all 1,358 compared values match. The app serves only the approved recommender method. Git tags record the frozen category, recommender and work-arrangement evaluations. The forecast model and selection rule are fixed before the reserved final week is scored.</a:t>
+              <a:t>On every push, GitHub runs more than 500 automated tests, checks the committed notebooks and builds the Docker images. The official build is recorded with six input fingerprints, and two rebuilds from the same inputs give identical copies of all 54 analytical output files. All nine notebooks run in strict mode, and the project check reports 0 errors and 0 warnings. SQL recomputes selected results from the row-level data, and all 1,358 compared values match. The app serves only the approved recommender method. Git tags record the frozen category, recommender and work-arrangement evaluations. I also rebuild the official outputs in Linux and compare them with Windows. All six input fingerprints match. Two files contain identical data with different compression, while three have small numerical differences. The categories, rankings, forecasts and reported findings remain unchanged. The forecast model and selection rule are fixed before the reserved final week is scored.</a:t>
             </a:r>
             <a:endParaRPr lang="en-US" dirty="0"/>
           </a:p>
@@ -4764,7 +4764,7 @@
         <p:spPr>
           <a:xfrm>
             <a:off x="548640" y="4434840"/>
-            <a:ext cx="6217920" cy="822960"/>
+            <a:ext cx="6217920" cy="1097280"/>
           </a:xfrm>
           <a:prstGeom prst="rect">
             <a:avLst/>
@@ -4785,7 +4785,7 @@
                   <a:schemeClr val="tx1"/>
                 </a:solidFill>
               </a:rPr>
-              <a:t>A Windows and Linux comparison of an earlier build matched except two files with small floating-point differences. It has not yet been repeated for the official build.</a:t>
+              <a:t>The official Windows and Linux builds use the same recorded inputs. Of 54 analytical files, 49 are byte-identical. The other five differ only in compression or small numerical values, without changing the main findings.</a:t>
             </a:r>
             <a:endParaRPr lang="en-US" sz="1600" dirty="0"/>
           </a:p>

</xml_diff>

<commit_message>
Notebook 09: post-evaluation diagnostics for category agreement over time and recommender test difficulty; docs updated to ten notebooks
</commit_message>
<xml_diff>
--- a/reports/job_market_presentation.pptx
+++ b/reports/job_market_presentation.pptx
@@ -918,7 +918,7 @@
           <a:p>
             <a:r>
               <a:rPr lang="en-US" dirty="0"/>
-              <a:t>On every push, GitHub runs more than 500 automated tests, checks the committed notebooks and builds the Docker images. The official build is recorded with six input fingerprints, and two rebuilds from the same inputs give identical copies of all 54 analytical output files. All nine notebooks run in strict mode, and the project check reports 0 errors and 0 warnings. SQL recomputes selected results from the row-level data, and all 1,358 compared values match. The app serves only the approved recommender method. Git tags record the frozen category, recommender and work-arrangement evaluations. I also rebuild the official outputs in Linux and compare them with Windows. All six input fingerprints match. Two files contain identical data with different compression, while three have small numerical differences. The categories, rankings, forecasts and reported findings remain unchanged. The forecast model and selection rule are fixed before the reserved final week is scored.</a:t>
+              <a:t>On every push, GitHub runs more than 500 automated tests, checks the committed notebooks and builds the Docker images. The official build is recorded with six input fingerprints, and two rebuilds from the same inputs give identical copies of all 54 analytical output files. All ten notebooks run in strict mode, and the project check reports 0 errors and 0 warnings. SQL recomputes selected results from the row-level data, and all 1,358 compared values match. The app serves only the approved recommender method. Git tags record the frozen category, recommender and work-arrangement evaluations. I also rebuild the official outputs in Linux and compare them with Windows. All six input fingerprints match. Two files contain identical data with different compression, while three have small numerical differences. The categories, rankings, forecasts and reported findings remain unchanged. The forecast model and selection rule are fixed before the reserved final week is scored.</a:t>
             </a:r>
             <a:endParaRPr lang="en-US" dirty="0"/>
           </a:p>
@@ -4418,7 +4418,7 @@
                   <a:schemeClr val="bg1"/>
                 </a:solidFill>
               </a:rPr>
-              <a:t>  strict project check; all 9 notebooks rerun on this build</a:t>
+              <a:t>  strict project check; all 10 notebooks run on this build</a:t>
             </a:r>
           </a:p>
           <a:p>

</xml_diff>